<commit_message>
Clarify AI-LST evidence, add antibody metric guide and synchronize editable figures
</commit_message>
<xml_diff>
--- a/editable/single/02_china_global_market.pptx
+++ b/editable/single/02_china_global_market.pptx
@@ -2,13 +2,13 @@
 <file path=ppt/presentation.xml><?xml version="1.0" encoding="utf-8"?>
 <p:presentation xmlns:p="http://schemas.openxmlformats.org/presentationml/2006/main">
   <p:sldMasterIdLst>
-    <p:sldMasterId xmlns:r="http://schemas.openxmlformats.org/officeDocument/2006/relationships" id="2147483648" r:id="R7398afe633064b0b"/>
+    <p:sldMasterId xmlns:r="http://schemas.openxmlformats.org/officeDocument/2006/relationships" id="2147483648" r:id="R3a28689f201b410d"/>
   </p:sldMasterIdLst>
   <p:notesMasterIdLst>
-    <p:notesMasterId xmlns:r="http://schemas.openxmlformats.org/officeDocument/2006/relationships" r:id="Rd9c1cebb8b394f62"/>
+    <p:notesMasterId xmlns:r="http://schemas.openxmlformats.org/officeDocument/2006/relationships" r:id="R2f6d5c1b19a74b8f"/>
   </p:notesMasterIdLst>
   <p:sldIdLst>
-    <p:sldId xmlns:r="http://schemas.openxmlformats.org/officeDocument/2006/relationships" id="256" r:id="R845dc929b9b74f5b"/>
+    <p:sldId xmlns:r="http://schemas.openxmlformats.org/officeDocument/2006/relationships" id="256" r:id="Rb9a68426c79d4477"/>
   </p:sldIdLst>
   <p:sldSz cx="18288000" cy="10287000"/>
   <p:notesSz cx="6858000" cy="9144000"/>
@@ -442,7 +442,7 @@
           <a:lstStyle xmlns:a="http://schemas.openxmlformats.org/drawingml/2006/main"/>
           <a:p xmlns:a="http://schemas.openxmlformats.org/drawingml/2006/main">
             <a:r>
-              <a:t>Figure 2: China and global LST markets</a:t>
+              <a:t>Figure 2: 2025 LST under one F&amp;S definition</a:t>
             </a:r>
           </a:p>
           <a:p xmlns:a="http://schemas.openxmlformats.org/drawingml/2006/main">
@@ -457,6 +457,371 @@
           </a:p>
           <a:p xmlns:a="http://schemas.openxmlformats.org/drawingml/2006/main">
             <a:r>
+              <a:t># Evidence review and implemented corrections</a:t>
+            </a:r>
+          </a:p>
+          <a:p xmlns:a="http://schemas.openxmlformats.org/drawingml/2006/main">
+            <a:r>
+              <a:t/>
+            </a:r>
+          </a:p>
+          <a:p xmlns:a="http://schemas.openxmlformats.org/drawingml/2006/main">
+            <a:r>
+              <a:t>Reviewed 13 October 2026. The website, affected figures and their PPT/PDF exports distinguish verified quotations from independently measured markets, analyst scenarios and unresolved source checks. The investment thesis is conditional on funded experiments and supplier orders.</a:t>
+            </a:r>
+          </a:p>
+          <a:p xmlns:a="http://schemas.openxmlformats.org/drawingml/2006/main">
+            <a:r>
+              <a:t/>
+            </a:r>
+          </a:p>
+          <a:p xmlns:a="http://schemas.openxmlformats.org/drawingml/2006/main">
+            <a:r>
+              <a:t>## Implemented changes</a:t>
+            </a:r>
+          </a:p>
+          <a:p xmlns:a="http://schemas.openxmlformats.org/drawingml/2006/main">
+            <a:r>
+              <a:t/>
+            </a:r>
+          </a:p>
+          <a:p xmlns:a="http://schemas.openxmlformats.org/drawingml/2006/main">
+            <a:r>
+              <a:t>- Figures 11–12 and the interactive funnel no longer present universal pre-AI/AI molecule counts or a synthetic cohort per clinical entrant. The page distinguishes small molecules from proteins/antibodies and uses 1× / 2× / 5× / 10× measurement-workload sensitivities. These are model inputs, not forecasts of fully profiled candidates.</a:t>
+            </a:r>
+          </a:p>
+          <a:p xmlns:a="http://schemas.openxmlformats.org/drawingml/2006/main">
+            <a:r>
+              <a:t>- Figure 03 replaces unsupported customer spending percentages with a qualitative product-use map. Research hospitals are explicit. Food, environmental and industrial-chemical uses are outside this life-science scope; clinical IVD analyzers are not included in research-instrument examples.</a:t>
+            </a:r>
+          </a:p>
+          <a:p xmlns:a="http://schemas.openxmlformats.org/drawingml/2006/main">
+            <a:r>
+              <a:t>- Figure 06 and the calculator separate physical quantities from spending. Price ratios, usable wells and reagent overhead are explicit scenario inputs.</a:t>
+            </a:r>
+          </a:p>
+          <a:p xmlns:a="http://schemas.openxmlformats.org/drawingml/2006/main">
+            <a:r>
+              <a:t>- Figure 07 replaces the unsupported 100% funding allocation with hypothetical total funding × 5% / 10% / 20% tool-purchase capture. These are cumulative sensitivities without a fixed horizon, not observed capital raised, vendor orders or annual TAM.</a:t>
+            </a:r>
+          </a:p>
+          <a:p xmlns:a="http://schemas.openxmlformats.org/drawingml/2006/main">
+            <a:r>
+              <a:t>- Figure 02 retains the quoted F&amp;S values and correct arithmetic but labels the issuer-commissioned scope. The China/global ratio is not multinational suppliers’ China revenue exposure.</a:t>
+            </a:r>
+          </a:p>
+          <a:p xmlns:a="http://schemas.openxmlformats.org/drawingml/2006/main">
+            <a:r>
+              <a:t>- Figure 12 retains the source-confirmed supplier/ticker map, labels recombinant-protein market disagreement and withholds the two Duoning headline market values pending source recovery.</a:t>
+            </a:r>
+          </a:p>
+          <a:p xmlns:a="http://schemas.openxmlformats.org/drawingml/2006/main">
+            <a:r>
+              <a:t/>
+            </a:r>
+          </a:p>
+          <a:p xmlns:a="http://schemas.openxmlformats.org/drawingml/2006/main">
+            <a:r>
+              <a:t>## Market quotations and remaining limitations</a:t>
+            </a:r>
+          </a:p>
+          <a:p xmlns:a="http://schemas.openxmlformats.org/drawingml/2006/main">
+            <a:r>
+              <a:t/>
+            </a:r>
+          </a:p>
+          <a:p xmlns:a="http://schemas.openxmlformats.org/drawingml/2006/main">
+            <a:r>
+              <a:t>### Four quoted anchors checked against their primary issuer documents</a:t>
+            </a:r>
+          </a:p>
+          <a:p xmlns:a="http://schemas.openxmlformats.org/drawingml/2006/main">
+            <a:r>
+              <a:t/>
+            </a:r>
+          </a:p>
+          <a:p xmlns:a="http://schemas.openxmlformats.org/drawingml/2006/main">
+            <a:r>
+              <a:t>1. China DNA-synthesis services, 2025: RMB1.33bn = RMB0.53bn oligonucleotide services + RMB0.80bn long-fragment services. Equipment, molecular reagents and sequencing are excluded. Tsingke prospectus, printed 1-1-158 / PDF159. [Primary filing](https://static.sse.com.cn/stock/disclosure/announcement/c/202606/002233_20260630_Z9LA.pdf).</a:t>
+            </a:r>
+          </a:p>
+          <a:p xmlns:a="http://schemas.openxmlformats.org/drawingml/2006/main">
+            <a:r>
+              <a:t>2. Global research-grade recombinant-protein reagents, 2025: US$3.5bn; China approximately US$0.4bn. ACRO filing, printed p.71 / PDF80. The issuer commissioned F&amp;S for RMB530,000, disclosed on printed p.63 / PDF72. This confirms the quotation and commissioning, not independent market measurement. [Primary filing](https://www1.hkexnews.hk/app/sehk/2026/108910/documents/sehk26093002651_c.pdf).</a:t>
+            </a:r>
+          </a:p>
+          <a:p xmlns:a="http://schemas.openxmlformats.org/drawingml/2006/main">
+            <a:r>
+              <a:t>3. China disposable plastic biological laboratory consumables, 2024: approximately RMB23bn. JET Biofil’s annual-report summary, PDF6, cites industry research. The broad scope includes research, clinical and industrial applications. A constant CAGR extrapolated from 2020 is not an independent validation. [Primary disclosure](https://static.cninfo.com.cn/finalpage/2026-04-30/1225255989.PDF).</a:t>
+            </a:r>
+          </a:p>
+          <a:p xmlns:a="http://schemas.openxmlformats.org/drawingml/2006/main">
+            <a:r>
+              <a:t>4. China sequencing instruments and consumables, 2024: RMB4.3bn. MGI annual report, pp.41–42, cites CIC/company/conference sources. The total includes clinical applications and does not size LC-MS, flow or imaging. Summing selected issuers’ China revenues is not a market check without harmonized product and geography definitions. [Primary disclosure](https://static.cninfo.com.cn/finalpage/2025-04-30/1223427376.PDF).</a:t>
+            </a:r>
+          </a:p>
+          <a:p xmlns:a="http://schemas.openxmlformats.org/drawingml/2006/main">
+            <a:r>
+              <a:t/>
+            </a:r>
+          </a:p>
+          <a:p xmlns:a="http://schemas.openxmlformats.org/drawingml/2006/main">
+            <a:r>
+              <a:t>### Protein estimates disagree; no harmonized range</a:t>
+            </a:r>
+          </a:p>
+          <a:p xmlns:a="http://schemas.openxmlformats.org/drawingml/2006/main">
+            <a:r>
+              <a:t/>
+            </a:r>
+          </a:p>
+          <a:p xmlns:a="http://schemas.openxmlformats.org/drawingml/2006/main">
+            <a:r>
+              <a:t>- F&amp;S/ACRO: US$3.5bn in 2025 for research-grade protein reagents, issuer commissioned.</a:t>
+            </a:r>
+          </a:p>
+          <a:p xmlns:a="http://schemas.openxmlformats.org/drawingml/2006/main">
+            <a:r>
+              <a:t>- MarketsandMarkets: US$1.11bn in 2026 for finished off-the-shelf research-use protein consumables. [Original release](https://www.marketsandmarkets.com/PressReleases/research-use-recombinant-protein.asp), [scope definition](https://www.marketsandmarkets.com/Market-Reports/research-use-recombinant-protein-market-156810846.html).</a:t>
+            </a:r>
+          </a:p>
+          <a:p xmlns:a="http://schemas.openxmlformats.org/drawingml/2006/main">
+            <a:r>
+              <a:t>- Global Market Insights: approximately US$2.5bn in 2025 for broader protein inputs and outsourced production services, including therapeutic and diagnostic uses. [Original report page](https://www.gminsights.com/industry-analysis/recombinant-proteins-market).</a:t>
+            </a:r>
+          </a:p>
+          <a:p xmlns:a="http://schemas.openxmlformats.org/drawingml/2006/main">
+            <a:r>
+              <a:t/>
+            </a:r>
+          </a:p>
+          <a:p xmlns:a="http://schemas.openxmlformats.org/drawingml/2006/main">
+            <a:r>
+              <a:t>Different years, product boundaries and methods prevent treating these figures as endpoints of a confidence interval. The disagreement warrants lower confidence in absolute TAM. It does not by itself prove F&amp;S inflated the market or identify one correct number. The source-specific historical series is not spliced with alternative providers.</a:t>
+            </a:r>
+          </a:p>
+          <a:p xmlns:a="http://schemas.openxmlformats.org/drawingml/2006/main">
+            <a:r>
+              <a:t/>
+            </a:r>
+          </a:p>
+          <a:p xmlns:a="http://schemas.openxmlformats.org/drawingml/2006/main">
+            <a:r>
+              <a:t>### Duoning values withheld from headlines</a:t>
+            </a:r>
+          </a:p>
+          <a:p xmlns:a="http://schemas.openxmlformats.org/drawingml/2006/main">
+            <a:r>
+              <a:t/>
+            </a:r>
+          </a:p>
+          <a:p xmlns:a="http://schemas.openxmlformats.org/drawingml/2006/main">
+            <a:r>
+              <a:t>Previous source notes cited China 2024 bioprocess media US$323.5m and bioprocess resins US$578.2m from the January2026 Duoning application, printed pp.126 and132. Its original Chinese and English full PDFs return404. The official index marks the application lapsed and no longer exposes full download links. Values and detailed exclusions have not been directly reverified in this review. They remain in source history as unverified prior citations, while headline cards and the funnel show “Source pending.” A search excerpt, derivative report, or assumed Protein A share does not restore original verification. [Official application index](https://www1.hkexnews.hk/app/appyearlyindex.html?lang=en&amp;year=2026).</a:t>
+            </a:r>
+          </a:p>
+          <a:p xmlns:a="http://schemas.openxmlformats.org/drawingml/2006/main">
+            <a:r>
+              <a:t/>
+            </a:r>
+          </a:p>
+          <a:p xmlns:a="http://schemas.openxmlformats.org/drawingml/2006/main">
+            <a:r>
+              <a:t>### Figure 02 uses one F&amp;S definition</a:t>
+            </a:r>
+          </a:p>
+          <a:p xmlns:a="http://schemas.openxmlformats.org/drawingml/2006/main">
+            <a:r>
+              <a:t/>
+            </a:r>
+          </a:p>
+          <a:p xmlns:a="http://schemas.openxmlformats.org/drawingml/2006/main">
+            <a:r>
+              <a:t>Quoted 2025 global/China LST estimates are US$41.5bn / US$7.7bn; research biological reagents US$26.4bn / US$4.6bn. Residual other tools are US$15.1bn / US$3.1bn. China/global = 7.7 /41.5 =18.554%, rounded18.6%. The residual is calculated and has not been split independently into instruments and consumables. Source: ACRO filing, printed pp.64–65 and67; commissioning p.63. Much larger broad tools/services estimates have different boundaries. Those boundaries have not been reconciled, and neither a broad-market alternative nor Western issuer geography percentages are replacement denominators.</a:t>
+            </a:r>
+          </a:p>
+          <a:p xmlns:a="http://schemas.openxmlformats.org/drawingml/2006/main">
+            <a:r>
+              <a:t/>
+            </a:r>
+          </a:p>
+          <a:p xmlns:a="http://schemas.openxmlformats.org/drawingml/2006/main">
+            <a:r>
+              <a:t>## Workflow and clinical evidence</a:t>
+            </a:r>
+          </a:p>
+          <a:p xmlns:a="http://schemas.openxmlformats.org/drawingml/2006/main">
+            <a:r>
+              <a:t/>
+            </a:r>
+          </a:p>
+          <a:p xmlns:a="http://schemas.openxmlformats.org/drawingml/2006/main">
+            <a:r>
+              <a:t>- Classical docking evaluated170 million compounds in2019 and synthesized/tested44 and549 for two targets. This is a study-level example, not a clinical-entrant cohort. [Lyu et al., Nature2019](https://www.nature.com/articles/s41586-019-0917-9).</a:t>
+            </a:r>
+          </a:p>
+          <a:p xmlns:a="http://schemas.openxmlformats.org/drawingml/2006/main">
+            <a:r>
+              <a:t>- A classical docking platform screened approximately1.3 billion compounds in2020. “Pre-AI” is not a universal cutoff; the distinction is method and workflow. [Gorgulla et al., Nature2020](https://pmc.ncbi.nlm.nih.gov/articles/PMC8352709/).</a:t>
+            </a:r>
+          </a:p>
+          <a:p xmlns:a="http://schemas.openxmlformats.org/drawingml/2006/main">
+            <a:r>
+              <a:t>- DSP-1181 was the350th compound synthesized in one company-reported program. [Sumitomo technical report2021, PDF4](https://www.sumitomo-chem.co.jp/english/rd/report/2021E_3.pdf).</a:t>
+            </a:r>
+          </a:p>
+          <a:p xmlns:a="http://schemas.openxmlformats.org/drawingml/2006/main">
+            <a:r>
+              <a:t>- REC-617 optimization synthesized136 novel compounds, according to company reporting. This is not a controlled industry-wide comparison. [Recursion2024 annual report](https://www.sec.gov/Archives/edgar/data/1601830/000160183025000064/rxrxannualreport2024.pdf).</a:t>
+            </a:r>
+          </a:p>
+          <a:p xmlns:a="http://schemas.openxmlformats.org/drawingml/2006/main">
+            <a:r>
+              <a:t>- Insilico’s78-molecule statement is company-reported and not used as a generic funnel parameter. The78 in a prominent Nature trial description refers to participants; these units must not be confused. [Company case study](https://insilico.com/casestudy).</a:t>
+            </a:r>
+          </a:p>
+          <a:p xmlns:a="http://schemas.openxmlformats.org/drawingml/2006/main">
+            <a:r>
+              <a:t>- Pooled protein screens and purified individual profiles are distinct. Bennett et al. screened approximately80,000 pooled designs then confirmed selected binders individually; substantial pooled protein screening also existed in2017. [Bennett et al.2023](https://www.nature.com/articles/s41467-023-38328-5), [Chevalier et al.2017](https://www.nature.com/articles/nature23912).</a:t>
+            </a:r>
+          </a:p>
+          <a:p xmlns:a="http://schemas.openxmlformats.org/drawingml/2006/main">
+            <a:r>
+              <a:t>- BIO’s7.9% Phase I-to-approval estimate covers2011–2020. Wong et al.’s13.8% covers2000–2015 with different data/methods. The two-study span is not a confidence interval, current consensus or an AI comparison. Neither is an expected output of the removed synthetic funnel. [BIO report](https://go.bio.org/rs/490-EHZ-999/images/ClinicalDevelopmentSuccessRates2011_2020.pdf), [Wong et al.](https://doi.org/10.1093/biostatistics/kxx069).</a:t>
+            </a:r>
+          </a:p>
+          <a:p xmlns:a="http://schemas.openxmlformats.org/drawingml/2006/main">
+            <a:r>
+              <a:t/>
+            </a:r>
+          </a:p>
+          <a:p xmlns:a="http://schemas.openxmlformats.org/drawingml/2006/main">
+            <a:r>
+              <a:t>## Unit-economics calculations</a:t>
+            </a:r>
+          </a:p>
+          <a:p xmlns:a="http://schemas.openxmlformats.org/drawingml/2006/main">
+            <a:r>
+              <a:t/>
+            </a:r>
+          </a:p>
+          <a:p xmlns:a="http://schemas.openxmlformats.org/drawingml/2006/main">
+            <a:r>
+              <a:t>Baseline:100,000 tests ×100µL =10L; ceil(100,000 /96)=1,042 destination plates;100,000 tips at1/test.</a:t>
+            </a:r>
+          </a:p>
+          <a:p xmlns:a="http://schemas.openxmlformats.org/drawingml/2006/main">
+            <a:r>
+              <a:t/>
+            </a:r>
+          </a:p>
+          <a:p xmlns:a="http://schemas.openxmlformats.org/drawingml/2006/main">
+            <a:r>
+              <a:t>Example:1,000,000 tests ×5µL =5L; ceil(1,000,000 /1,536)=652 destination plates;100,000 tips at0.1/test.</a:t>
+            </a:r>
+          </a:p>
+          <a:p xmlns:a="http://schemas.openxmlformats.org/drawingml/2006/main">
+            <a:r>
+              <a:t/>
+            </a:r>
+          </a:p>
+          <a:p xmlns:a="http://schemas.openxmlformats.org/drawingml/2006/main">
+            <a:r>
+              <a:t>Plate-count ratio =652/1,042 =0.625720. Plate-spend ratio =0.625720 × comparable plate ASP ratio. Break-even ASP =1,042/652 =1.598160. At1×/2×/4× ASP, spend ratios are0.625720 /1.251440 /2.502879. These price multipliers are scenario inputs, not vendor quotes. The review’s “plastic spend probably rises” is not established without equivalent product quotes and consumption scope.</a:t>
+            </a:r>
+          </a:p>
+          <a:p xmlns:a="http://schemas.openxmlformats.org/drawingml/2006/main">
+            <a:r>
+              <a:t/>
+            </a:r>
+          </a:p>
+          <a:p xmlns:a="http://schemas.openxmlformats.org/drawingml/2006/main">
+            <a:r>
+              <a:t>Calculator reagent volume =tests ×usable assay µL ×(1 + case-specific extra-reagent overhead)/1,000,000. The baseline uses its own overhead input. New destination plates =ceil(tests /floor(wells ×usable-well fraction)); baseline plates assume100% usable wells. Price ratios multiply quantity ratios separately for reagent, plate and tip spend. Real workflows can also require source plates, reservoirs, controls, retests and instrument capital. [Beckman’s source-container and dead-volume documentation](https://www.beckman.com/supplies/echo-qualified-supplies). Average tips/test is a model input, not a recommendation to reuse biological-sample tips.</a:t>
+            </a:r>
+          </a:p>
+          <a:p xmlns:a="http://schemas.openxmlformats.org/drawingml/2006/main">
+            <a:r>
+              <a:t/>
+            </a:r>
+          </a:p>
+          <a:p xmlns:a="http://schemas.openxmlformats.org/drawingml/2006/main">
+            <a:r>
+              <a:t>Funding scenarios:US$50/100/200bn ×5%/10%/20% capture imply cumulative tool purchases of [2.5,5,10] / [5,10,20] / [10,20,40] US$bn. No fixed time horizon or empirical capture share is asserted. Exclude labor, clinical execution, compute/data/software, facilities and funding not spent on tools. CRO fees and embedded vendor-input purchases must not be added together. [Recursion2025 10-K](https://www.sec.gov/Archives/edgar/data/1601830/000160183026000039/rxrx-20251231.htm), pp.147–148, illustrates diverse R&amp;D cost categories, not universal cash shares.</a:t>
+            </a:r>
+          </a:p>
+          <a:p xmlns:a="http://schemas.openxmlformats.org/drawingml/2006/main">
+            <a:r>
+              <a:t/>
+            </a:r>
+          </a:p>
+          <a:p xmlns:a="http://schemas.openxmlformats.org/drawingml/2006/main">
+            <a:r>
+              <a:t>An incremental equipment budget need not resemble the composition of existing annual tool sales. The reviewer’s30% equipment versus64% market-reagents comparison alone is not an arithmetic contradiction. Unsupported allocation shares were removed because their evidential basis was missing.</a:t>
+            </a:r>
+          </a:p>
+          <a:p xmlns:a="http://schemas.openxmlformats.org/drawingml/2006/main">
+            <a:r>
+              <a:t/>
+            </a:r>
+          </a:p>
+          <a:p xmlns:a="http://schemas.openxmlformats.org/drawingml/2006/main">
+            <a:r>
+              <a:t>## Current sequencing-policy correction</a:t>
+            </a:r>
+          </a:p>
+          <a:p xmlns:a="http://schemas.openxmlformats.org/drawingml/2006/main">
+            <a:r>
+              <a:t/>
+            </a:r>
+          </a:p>
+          <a:p xmlns:a="http://schemas.openxmlformats.org/drawingml/2006/main">
+            <a:r>
+              <a:t>China’s blanket Illumina sequencer-export prohibition introduced on4March2025 ended on10November2025. Illumina remained on the Unreliable Entity List and instrument purchases required government approval, confirmed in its2026-filed annual report. The reviewer’s ongoing blanket-ban statement is outdated. The2024 anchor remains a dated source estimate rather than a current policy-adjusted TAM. [Illumina announcement](https://www.illumina.com/company/news-center/press-releases/2025/97cd0e7b-b018-4ab8-beb0-0f538b164ae6.html), [MOFCOM update](https://exportcontrol.mofcom.gov.cn/article/gndt/202511/1187.html), [2025 annual report filed2026](https://www.sec.gov/Archives/edgar/data/1110803/000111080326000024/ilmn-20251228.htm).</a:t>
+            </a:r>
+          </a:p>
+          <a:p xmlns:a="http://schemas.openxmlformats.org/drawingml/2006/main">
+            <a:r>
+              <a:t/>
+            </a:r>
+          </a:p>
+          <a:p xmlns:a="http://schemas.openxmlformats.org/drawingml/2006/main">
+            <a:r>
+              <a:t>BD/Waters ownership and verified supplier tickers remain as previously sourced in palette/TICKER_SOURCES.md. This review does not establish any supplier’s AI-attributable revenue, market share or valuation upside.</a:t>
+            </a:r>
+          </a:p>
+          <a:p xmlns:a="http://schemas.openxmlformats.org/drawingml/2006/main">
+            <a:r>
+              <a:t/>
+            </a:r>
+          </a:p>
+          <a:p xmlns:a="http://schemas.openxmlformats.org/drawingml/2006/main">
+            <a:r>
+              <a:t/>
+            </a:r>
+          </a:p>
+          <a:p xmlns:a="http://schemas.openxmlformats.org/drawingml/2006/main">
+            <a:r>
+              <a:t>## Superseded source history</a:t>
+            </a:r>
+          </a:p>
+          <a:p xmlns:a="http://schemas.openxmlformats.org/drawingml/2006/main">
+            <a:r>
+              <a:t/>
+            </a:r>
+          </a:p>
+          <a:p xmlns:a="http://schemas.openxmlformats.org/drawingml/2006/main">
+            <a:r>
+              <a:t>The following preserves prior citation history. Its universal molecule counts, customer-percentage assumptions, funding allocation and Duoning headline figures were superseded by the review above and must not be used as current inputs.</a:t>
+            </a:r>
+          </a:p>
+          <a:p xmlns:a="http://schemas.openxmlformats.org/drawingml/2006/main">
+            <a:r>
+              <a:t/>
+            </a:r>
+          </a:p>
+          <a:p xmlns:a="http://schemas.openxmlformats.org/drawingml/2006/main">
+            <a:r>
               <a:t># Sources, assumptions and market boundaries</a:t>
             </a:r>
           </a:p>
@@ -983,6 +1348,341 @@
           <a:p xmlns:a="http://schemas.openxmlformats.org/drawingml/2006/main">
             <a:r>
               <a:t/>
+            </a:r>
+          </a:p>
+          <a:p xmlns:a="http://schemas.openxmlformats.org/drawingml/2006/main">
+            <a:r>
+              <a:t># Evidence review and implemented corrections</a:t>
+            </a:r>
+          </a:p>
+          <a:p xmlns:a="http://schemas.openxmlformats.org/drawingml/2006/main">
+            <a:r>
+              <a:t/>
+            </a:r>
+          </a:p>
+          <a:p xmlns:a="http://schemas.openxmlformats.org/drawingml/2006/main">
+            <a:r>
+              <a:t>Reviewed 13 October 2026. The website, affected figures and their PPT/PDF exports distinguish verified quotations from independently measured markets, analyst scenarios and unresolved source checks. The investment thesis is conditional on funded experiments and supplier orders.</a:t>
+            </a:r>
+          </a:p>
+          <a:p xmlns:a="http://schemas.openxmlformats.org/drawingml/2006/main">
+            <a:r>
+              <a:t/>
+            </a:r>
+          </a:p>
+          <a:p xmlns:a="http://schemas.openxmlformats.org/drawingml/2006/main">
+            <a:r>
+              <a:t>## Implemented changes</a:t>
+            </a:r>
+          </a:p>
+          <a:p xmlns:a="http://schemas.openxmlformats.org/drawingml/2006/main">
+            <a:r>
+              <a:t/>
+            </a:r>
+          </a:p>
+          <a:p xmlns:a="http://schemas.openxmlformats.org/drawingml/2006/main">
+            <a:r>
+              <a:t>- Figures 11–12 and the interactive funnel no longer present universal pre-AI/AI molecule counts or a synthetic cohort per clinical entrant. The page distinguishes small molecules from proteins/antibodies and uses 1× / 2× / 5× / 10× measurement-workload sensitivities. These are model inputs, not forecasts of fully profiled candidates.</a:t>
+            </a:r>
+          </a:p>
+          <a:p xmlns:a="http://schemas.openxmlformats.org/drawingml/2006/main">
+            <a:r>
+              <a:t>- Figure 03 replaces unsupported customer spending percentages with a qualitative product-use map. Research hospitals are explicit. Food, environmental and industrial-chemical uses are outside this life-science scope; clinical IVD analyzers are not included in research-instrument examples.</a:t>
+            </a:r>
+          </a:p>
+          <a:p xmlns:a="http://schemas.openxmlformats.org/drawingml/2006/main">
+            <a:r>
+              <a:t>- Figure 06 and the calculator separate physical quantities from spending. Price ratios, usable wells and reagent overhead are explicit scenario inputs.</a:t>
+            </a:r>
+          </a:p>
+          <a:p xmlns:a="http://schemas.openxmlformats.org/drawingml/2006/main">
+            <a:r>
+              <a:t>- Figure 07 replaces the unsupported 100% funding allocation with hypothetical total funding × 5% / 10% / 20% tool-purchase capture. These are cumulative sensitivities without a fixed horizon, not observed capital raised, vendor orders or annual TAM.</a:t>
+            </a:r>
+          </a:p>
+          <a:p xmlns:a="http://schemas.openxmlformats.org/drawingml/2006/main">
+            <a:r>
+              <a:t>- Figure 02 retains the quoted F&amp;S values and correct arithmetic but labels the issuer-commissioned scope. The China/global ratio is not multinational suppliers’ China revenue exposure.</a:t>
+            </a:r>
+          </a:p>
+          <a:p xmlns:a="http://schemas.openxmlformats.org/drawingml/2006/main">
+            <a:r>
+              <a:t>- Figure 12 retains the source-confirmed supplier/ticker map, labels recombinant-protein market disagreement and withholds the two Duoning headline market values pending source recovery.</a:t>
+            </a:r>
+          </a:p>
+          <a:p xmlns:a="http://schemas.openxmlformats.org/drawingml/2006/main">
+            <a:r>
+              <a:t/>
+            </a:r>
+          </a:p>
+          <a:p xmlns:a="http://schemas.openxmlformats.org/drawingml/2006/main">
+            <a:r>
+              <a:t>## Market quotations and remaining limitations</a:t>
+            </a:r>
+          </a:p>
+          <a:p xmlns:a="http://schemas.openxmlformats.org/drawingml/2006/main">
+            <a:r>
+              <a:t/>
+            </a:r>
+          </a:p>
+          <a:p xmlns:a="http://schemas.openxmlformats.org/drawingml/2006/main">
+            <a:r>
+              <a:t>### Four quoted anchors checked against their primary issuer documents</a:t>
+            </a:r>
+          </a:p>
+          <a:p xmlns:a="http://schemas.openxmlformats.org/drawingml/2006/main">
+            <a:r>
+              <a:t/>
+            </a:r>
+          </a:p>
+          <a:p xmlns:a="http://schemas.openxmlformats.org/drawingml/2006/main">
+            <a:r>
+              <a:t>1. China DNA-synthesis services, 2025: RMB1.33bn = RMB0.53bn oligonucleotide services + RMB0.80bn long-fragment services. Equipment, molecular reagents and sequencing are excluded. Tsingke prospectus, printed 1-1-158 / PDF159. [Primary filing](https://static.sse.com.cn/stock/disclosure/announcement/c/202606/002233_20260630_Z9LA.pdf).</a:t>
+            </a:r>
+          </a:p>
+          <a:p xmlns:a="http://schemas.openxmlformats.org/drawingml/2006/main">
+            <a:r>
+              <a:t>2. Global research-grade recombinant-protein reagents, 2025: US$3.5bn; China approximately US$0.4bn. ACRO filing, printed p.71 / PDF80. The issuer commissioned F&amp;S for RMB530,000, disclosed on printed p.63 / PDF72. This confirms the quotation and commissioning, not independent market measurement. [Primary filing](https://www1.hkexnews.hk/app/sehk/2026/108910/documents/sehk26093002651_c.pdf).</a:t>
+            </a:r>
+          </a:p>
+          <a:p xmlns:a="http://schemas.openxmlformats.org/drawingml/2006/main">
+            <a:r>
+              <a:t>3. China disposable plastic biological laboratory consumables, 2024: approximately RMB23bn. JET Biofil’s annual-report summary, PDF6, cites industry research. The broad scope includes research, clinical and industrial applications. A constant CAGR extrapolated from 2020 is not an independent validation. [Primary disclosure](https://static.cninfo.com.cn/finalpage/2026-04-30/1225255989.PDF).</a:t>
+            </a:r>
+          </a:p>
+          <a:p xmlns:a="http://schemas.openxmlformats.org/drawingml/2006/main">
+            <a:r>
+              <a:t>4. China sequencing instruments and consumables, 2024: RMB4.3bn. MGI annual report, pp.41–42, cites CIC/company/conference sources. The total includes clinical applications and does not size LC-MS, flow or imaging. Summing selected issuers’ China revenues is not a market check without harmonized product and geography definitions. [Primary disclosure](https://static.cninfo.com.cn/finalpage/2025-04-30/1223427376.PDF).</a:t>
+            </a:r>
+          </a:p>
+          <a:p xmlns:a="http://schemas.openxmlformats.org/drawingml/2006/main">
+            <a:r>
+              <a:t/>
+            </a:r>
+          </a:p>
+          <a:p xmlns:a="http://schemas.openxmlformats.org/drawingml/2006/main">
+            <a:r>
+              <a:t>### Protein estimates disagree; no harmonized range</a:t>
+            </a:r>
+          </a:p>
+          <a:p xmlns:a="http://schemas.openxmlformats.org/drawingml/2006/main">
+            <a:r>
+              <a:t/>
+            </a:r>
+          </a:p>
+          <a:p xmlns:a="http://schemas.openxmlformats.org/drawingml/2006/main">
+            <a:r>
+              <a:t>- F&amp;S/ACRO: US$3.5bn in 2025 for research-grade protein reagents, issuer commissioned.</a:t>
+            </a:r>
+          </a:p>
+          <a:p xmlns:a="http://schemas.openxmlformats.org/drawingml/2006/main">
+            <a:r>
+              <a:t>- MarketsandMarkets: US$1.11bn in 2026 for finished off-the-shelf research-use protein consumables. [Original release](https://www.marketsandmarkets.com/PressReleases/research-use-recombinant-protein.asp), [scope definition](https://www.marketsandmarkets.com/Market-Reports/research-use-recombinant-protein-market-156810846.html).</a:t>
+            </a:r>
+          </a:p>
+          <a:p xmlns:a="http://schemas.openxmlformats.org/drawingml/2006/main">
+            <a:r>
+              <a:t>- Global Market Insights: approximately US$2.5bn in 2025 for broader protein inputs and outsourced production services, including therapeutic and diagnostic uses. [Original report page](https://www.gminsights.com/industry-analysis/recombinant-proteins-market).</a:t>
+            </a:r>
+          </a:p>
+          <a:p xmlns:a="http://schemas.openxmlformats.org/drawingml/2006/main">
+            <a:r>
+              <a:t/>
+            </a:r>
+          </a:p>
+          <a:p xmlns:a="http://schemas.openxmlformats.org/drawingml/2006/main">
+            <a:r>
+              <a:t>Different years, product boundaries and methods prevent treating these figures as endpoints of a confidence interval. The disagreement warrants lower confidence in absolute TAM. It does not by itself prove F&amp;S inflated the market or identify one correct number. The source-specific historical series is not spliced with alternative providers.</a:t>
+            </a:r>
+          </a:p>
+          <a:p xmlns:a="http://schemas.openxmlformats.org/drawingml/2006/main">
+            <a:r>
+              <a:t/>
+            </a:r>
+          </a:p>
+          <a:p xmlns:a="http://schemas.openxmlformats.org/drawingml/2006/main">
+            <a:r>
+              <a:t>### Duoning values withheld from headlines</a:t>
+            </a:r>
+          </a:p>
+          <a:p xmlns:a="http://schemas.openxmlformats.org/drawingml/2006/main">
+            <a:r>
+              <a:t/>
+            </a:r>
+          </a:p>
+          <a:p xmlns:a="http://schemas.openxmlformats.org/drawingml/2006/main">
+            <a:r>
+              <a:t>Previous source notes cited China 2024 bioprocess media US$323.5m and bioprocess resins US$578.2m from the January2026 Duoning application, printed pp.126 and132. Its original Chinese and English full PDFs return404. The official index marks the application lapsed and no longer exposes full download links. Values and detailed exclusions have not been directly reverified in this review. They remain in source history as unverified prior citations, while headline cards and the funnel show “Source pending.” A search excerpt, derivative report, or assumed Protein A share does not restore original verification. [Official application index](https://www1.hkexnews.hk/app/appyearlyindex.html?lang=en&amp;year=2026).</a:t>
+            </a:r>
+          </a:p>
+          <a:p xmlns:a="http://schemas.openxmlformats.org/drawingml/2006/main">
+            <a:r>
+              <a:t/>
+            </a:r>
+          </a:p>
+          <a:p xmlns:a="http://schemas.openxmlformats.org/drawingml/2006/main">
+            <a:r>
+              <a:t>### Figure 02 uses one F&amp;S definition</a:t>
+            </a:r>
+          </a:p>
+          <a:p xmlns:a="http://schemas.openxmlformats.org/drawingml/2006/main">
+            <a:r>
+              <a:t/>
+            </a:r>
+          </a:p>
+          <a:p xmlns:a="http://schemas.openxmlformats.org/drawingml/2006/main">
+            <a:r>
+              <a:t>Quoted 2025 global/China LST estimates are US$41.5bn / US$7.7bn; research biological reagents US$26.4bn / US$4.6bn. Residual other tools are US$15.1bn / US$3.1bn. China/global = 7.7 /41.5 =18.554%, rounded18.6%. The residual is calculated and has not been split independently into instruments and consumables. Source: ACRO filing, printed pp.64–65 and67; commissioning p.63. Much larger broad tools/services estimates have different boundaries. Those boundaries have not been reconciled, and neither a broad-market alternative nor Western issuer geography percentages are replacement denominators.</a:t>
+            </a:r>
+          </a:p>
+          <a:p xmlns:a="http://schemas.openxmlformats.org/drawingml/2006/main">
+            <a:r>
+              <a:t/>
+            </a:r>
+          </a:p>
+          <a:p xmlns:a="http://schemas.openxmlformats.org/drawingml/2006/main">
+            <a:r>
+              <a:t>## Workflow and clinical evidence</a:t>
+            </a:r>
+          </a:p>
+          <a:p xmlns:a="http://schemas.openxmlformats.org/drawingml/2006/main">
+            <a:r>
+              <a:t/>
+            </a:r>
+          </a:p>
+          <a:p xmlns:a="http://schemas.openxmlformats.org/drawingml/2006/main">
+            <a:r>
+              <a:t>- Classical docking evaluated170 million compounds in2019 and synthesized/tested44 and549 for two targets. This is a study-level example, not a clinical-entrant cohort. [Lyu et al., Nature2019](https://www.nature.com/articles/s41586-019-0917-9).</a:t>
+            </a:r>
+          </a:p>
+          <a:p xmlns:a="http://schemas.openxmlformats.org/drawingml/2006/main">
+            <a:r>
+              <a:t>- A classical docking platform screened approximately1.3 billion compounds in2020. “Pre-AI” is not a universal cutoff; the distinction is method and workflow. [Gorgulla et al., Nature2020](https://pmc.ncbi.nlm.nih.gov/articles/PMC8352709/).</a:t>
+            </a:r>
+          </a:p>
+          <a:p xmlns:a="http://schemas.openxmlformats.org/drawingml/2006/main">
+            <a:r>
+              <a:t>- DSP-1181 was the350th compound synthesized in one company-reported program. [Sumitomo technical report2021, PDF4](https://www.sumitomo-chem.co.jp/english/rd/report/2021E_3.pdf).</a:t>
+            </a:r>
+          </a:p>
+          <a:p xmlns:a="http://schemas.openxmlformats.org/drawingml/2006/main">
+            <a:r>
+              <a:t>- REC-617 optimization synthesized136 novel compounds, according to company reporting. This is not a controlled industry-wide comparison. [Recursion2024 annual report](https://www.sec.gov/Archives/edgar/data/1601830/000160183025000064/rxrxannualreport2024.pdf).</a:t>
+            </a:r>
+          </a:p>
+          <a:p xmlns:a="http://schemas.openxmlformats.org/drawingml/2006/main">
+            <a:r>
+              <a:t>- Insilico’s78-molecule statement is company-reported and not used as a generic funnel parameter. The78 in a prominent Nature trial description refers to participants; these units must not be confused. [Company case study](https://insilico.com/casestudy).</a:t>
+            </a:r>
+          </a:p>
+          <a:p xmlns:a="http://schemas.openxmlformats.org/drawingml/2006/main">
+            <a:r>
+              <a:t>- Pooled protein screens and purified individual profiles are distinct. Bennett et al. screened approximately80,000 pooled designs then confirmed selected binders individually; substantial pooled protein screening also existed in2017. [Bennett et al.2023](https://www.nature.com/articles/s41467-023-38328-5), [Chevalier et al.2017](https://www.nature.com/articles/nature23912).</a:t>
+            </a:r>
+          </a:p>
+          <a:p xmlns:a="http://schemas.openxmlformats.org/drawingml/2006/main">
+            <a:r>
+              <a:t>- BIO’s7.9% Phase I-to-approval estimate covers2011–2020. Wong et al.’s13.8% covers2000–2015 with different data/methods. The two-study span is not a confidence interval, current consensus or an AI comparison. Neither is an expected output of the removed synthetic funnel. [BIO report](https://go.bio.org/rs/490-EHZ-999/images/ClinicalDevelopmentSuccessRates2011_2020.pdf), [Wong et al.](https://doi.org/10.1093/biostatistics/kxx069).</a:t>
+            </a:r>
+          </a:p>
+          <a:p xmlns:a="http://schemas.openxmlformats.org/drawingml/2006/main">
+            <a:r>
+              <a:t/>
+            </a:r>
+          </a:p>
+          <a:p xmlns:a="http://schemas.openxmlformats.org/drawingml/2006/main">
+            <a:r>
+              <a:t>## Unit-economics calculations</a:t>
+            </a:r>
+          </a:p>
+          <a:p xmlns:a="http://schemas.openxmlformats.org/drawingml/2006/main">
+            <a:r>
+              <a:t/>
+            </a:r>
+          </a:p>
+          <a:p xmlns:a="http://schemas.openxmlformats.org/drawingml/2006/main">
+            <a:r>
+              <a:t>Baseline:100,000 tests ×100µL =10L; ceil(100,000 /96)=1,042 destination plates;100,000 tips at1/test.</a:t>
+            </a:r>
+          </a:p>
+          <a:p xmlns:a="http://schemas.openxmlformats.org/drawingml/2006/main">
+            <a:r>
+              <a:t/>
+            </a:r>
+          </a:p>
+          <a:p xmlns:a="http://schemas.openxmlformats.org/drawingml/2006/main">
+            <a:r>
+              <a:t>Example:1,000,000 tests ×5µL =5L; ceil(1,000,000 /1,536)=652 destination plates;100,000 tips at0.1/test.</a:t>
+            </a:r>
+          </a:p>
+          <a:p xmlns:a="http://schemas.openxmlformats.org/drawingml/2006/main">
+            <a:r>
+              <a:t/>
+            </a:r>
+          </a:p>
+          <a:p xmlns:a="http://schemas.openxmlformats.org/drawingml/2006/main">
+            <a:r>
+              <a:t>Plate-count ratio =652/1,042 =0.625720. Plate-spend ratio =0.625720 × comparable plate ASP ratio. Break-even ASP =1,042/652 =1.598160. At1×/2×/4× ASP, spend ratios are0.625720 /1.251440 /2.502879. These price multipliers are scenario inputs, not vendor quotes. The review’s “plastic spend probably rises” is not established without equivalent product quotes and consumption scope.</a:t>
+            </a:r>
+          </a:p>
+          <a:p xmlns:a="http://schemas.openxmlformats.org/drawingml/2006/main">
+            <a:r>
+              <a:t/>
+            </a:r>
+          </a:p>
+          <a:p xmlns:a="http://schemas.openxmlformats.org/drawingml/2006/main">
+            <a:r>
+              <a:t>Calculator reagent volume =tests ×usable assay µL ×(1 + case-specific extra-reagent overhead)/1,000,000. The baseline uses its own overhead input. New destination plates =ceil(tests /floor(wells ×usable-well fraction)); baseline plates assume100% usable wells. Price ratios multiply quantity ratios separately for reagent, plate and tip spend. Real workflows can also require source plates, reservoirs, controls, retests and instrument capital. [Beckman’s source-container and dead-volume documentation](https://www.beckman.com/supplies/echo-qualified-supplies). Average tips/test is a model input, not a recommendation to reuse biological-sample tips.</a:t>
+            </a:r>
+          </a:p>
+          <a:p xmlns:a="http://schemas.openxmlformats.org/drawingml/2006/main">
+            <a:r>
+              <a:t/>
+            </a:r>
+          </a:p>
+          <a:p xmlns:a="http://schemas.openxmlformats.org/drawingml/2006/main">
+            <a:r>
+              <a:t>Funding scenarios:US$50/100/200bn ×5%/10%/20% capture imply cumulative tool purchases of [2.5,5,10] / [5,10,20] / [10,20,40] US$bn. No fixed time horizon or empirical capture share is asserted. Exclude labor, clinical execution, compute/data/software, facilities and funding not spent on tools. CRO fees and embedded vendor-input purchases must not be added together. [Recursion2025 10-K](https://www.sec.gov/Archives/edgar/data/1601830/000160183026000039/rxrx-20251231.htm), pp.147–148, illustrates diverse R&amp;D cost categories, not universal cash shares.</a:t>
+            </a:r>
+          </a:p>
+          <a:p xmlns:a="http://schemas.openxmlformats.org/drawingml/2006/main">
+            <a:r>
+              <a:t/>
+            </a:r>
+          </a:p>
+          <a:p xmlns:a="http://schemas.openxmlformats.org/drawingml/2006/main">
+            <a:r>
+              <a:t>An incremental equipment budget need not resemble the composition of existing annual tool sales. The reviewer’s30% equipment versus64% market-reagents comparison alone is not an arithmetic contradiction. Unsupported allocation shares were removed because their evidential basis was missing.</a:t>
+            </a:r>
+          </a:p>
+          <a:p xmlns:a="http://schemas.openxmlformats.org/drawingml/2006/main">
+            <a:r>
+              <a:t/>
+            </a:r>
+          </a:p>
+          <a:p xmlns:a="http://schemas.openxmlformats.org/drawingml/2006/main">
+            <a:r>
+              <a:t>## Current sequencing-policy correction</a:t>
+            </a:r>
+          </a:p>
+          <a:p xmlns:a="http://schemas.openxmlformats.org/drawingml/2006/main">
+            <a:r>
+              <a:t/>
+            </a:r>
+          </a:p>
+          <a:p xmlns:a="http://schemas.openxmlformats.org/drawingml/2006/main">
+            <a:r>
+              <a:t>China’s blanket Illumina sequencer-export prohibition introduced on4March2025 ended on10November2025. Illumina remained on the Unreliable Entity List and instrument purchases required government approval, confirmed in its2026-filed annual report. The reviewer’s ongoing blanket-ban statement is outdated. The2024 anchor remains a dated source estimate rather than a current policy-adjusted TAM. [Illumina announcement](https://www.illumina.com/company/news-center/press-releases/2025/97cd0e7b-b018-4ab8-beb0-0f538b164ae6.html), [MOFCOM update](https://exportcontrol.mofcom.gov.cn/article/gndt/202511/1187.html), [2025 annual report filed2026](https://www.sec.gov/Archives/edgar/data/1110803/000111080326000024/ilmn-20251228.htm).</a:t>
+            </a:r>
+          </a:p>
+          <a:p xmlns:a="http://schemas.openxmlformats.org/drawingml/2006/main">
+            <a:r>
+              <a:t/>
+            </a:r>
+          </a:p>
+          <a:p xmlns:a="http://schemas.openxmlformats.org/drawingml/2006/main">
+            <a:r>
+              <a:t>BD/Waters ownership and verified supplier tickers remain as previously sourced in palette/TICKER_SOURCES.md. This review does not establish any supplier’s AI-attributable revenue, market share or valuation upside.</a:t>
             </a:r>
           </a:p>
           <a:p xmlns:a="http://schemas.openxmlformats.org/drawingml/2006/main">
@@ -1034,7 +1734,7 @@
           <p:cNvPr id="3" name="Title">
             <a:extLst xmlns:a="http://schemas.openxmlformats.org/drawingml/2006/main">
               <a:ext uri="{FF2B5EF4-FFF2-40B4-BE49-F238E27FC236}">
-                <a16:creationId xmlns:a16="http://schemas.microsoft.com/office/drawing/2014/main" id="{E44B83A0-09A3-4FEF-BED1-91F4F6EC598D}"/>
+                <a16:creationId xmlns:a16="http://schemas.microsoft.com/office/drawing/2014/main" id="{DBFB759D-1B44-4F72-8920-248307E87C37}"/>
               </a:ext>
             </a:extLst>
           </p:cNvPr>
@@ -1200,7 +1900,7 @@
           <p:cNvPr id="2" name="Subtitle">
             <a:extLst xmlns:a="http://schemas.openxmlformats.org/drawingml/2006/main">
               <a:ext uri="{FF2B5EF4-FFF2-40B4-BE49-F238E27FC236}">
-                <a16:creationId xmlns:a16="http://schemas.microsoft.com/office/drawing/2014/main" id="{E27ED62F-A26A-4B02-9977-44A221FE2041}"/>
+                <a16:creationId xmlns:a16="http://schemas.microsoft.com/office/drawing/2014/main" id="{2C1BD9ED-08F1-434B-A3F0-AEFD432FE35F}"/>
               </a:ext>
             </a:extLst>
           </p:cNvPr>
@@ -1383,7 +2083,7 @@
           <p:cNvPr id="2" name="Section title">
             <a:extLst xmlns:a="http://schemas.openxmlformats.org/drawingml/2006/main">
               <a:ext uri="{FF2B5EF4-FFF2-40B4-BE49-F238E27FC236}">
-                <a16:creationId xmlns:a16="http://schemas.microsoft.com/office/drawing/2014/main" id="{C0C5D465-0DB3-492B-BDED-914A8B179FE4}"/>
+                <a16:creationId xmlns:a16="http://schemas.microsoft.com/office/drawing/2014/main" id="{FBCEEEA3-4F54-4720-869C-B399EB779CCA}"/>
               </a:ext>
             </a:extLst>
           </p:cNvPr>
@@ -1566,7 +2266,7 @@
           <p:cNvPr id="3" name="Title">
             <a:extLst xmlns:a="http://schemas.openxmlformats.org/drawingml/2006/main">
               <a:ext uri="{FF2B5EF4-FFF2-40B4-BE49-F238E27FC236}">
-                <a16:creationId xmlns:a16="http://schemas.microsoft.com/office/drawing/2014/main" id="{AFC0EAB4-7F12-4015-9B6D-96A0FAC6F152}"/>
+                <a16:creationId xmlns:a16="http://schemas.microsoft.com/office/drawing/2014/main" id="{BF02694E-3D17-4BFB-B7D4-AC273DD50960}"/>
               </a:ext>
             </a:extLst>
           </p:cNvPr>
@@ -1732,7 +2432,7 @@
           <p:cNvPr id="2" name="Body">
             <a:extLst xmlns:a="http://schemas.openxmlformats.org/drawingml/2006/main">
               <a:ext uri="{FF2B5EF4-FFF2-40B4-BE49-F238E27FC236}">
-                <a16:creationId xmlns:a16="http://schemas.microsoft.com/office/drawing/2014/main" id="{8E4CABBE-B501-4C05-A776-B0D0671CC626}"/>
+                <a16:creationId xmlns:a16="http://schemas.microsoft.com/office/drawing/2014/main" id="{357C04FC-973E-46AE-91AF-79868278FB4D}"/>
               </a:ext>
             </a:extLst>
           </p:cNvPr>
@@ -1915,7 +2615,7 @@
           <p:cNvPr id="4" name="Title">
             <a:extLst xmlns:a="http://schemas.openxmlformats.org/drawingml/2006/main">
               <a:ext uri="{FF2B5EF4-FFF2-40B4-BE49-F238E27FC236}">
-                <a16:creationId xmlns:a16="http://schemas.microsoft.com/office/drawing/2014/main" id="{C75DF615-7C56-41F2-86D4-2A107540C9D1}"/>
+                <a16:creationId xmlns:a16="http://schemas.microsoft.com/office/drawing/2014/main" id="{C3541FC5-6A13-490F-B490-16D3BDD937C4}"/>
               </a:ext>
             </a:extLst>
           </p:cNvPr>
@@ -2081,7 +2781,7 @@
           <p:cNvPr id="2" name="Left column">
             <a:extLst xmlns:a="http://schemas.openxmlformats.org/drawingml/2006/main">
               <a:ext uri="{FF2B5EF4-FFF2-40B4-BE49-F238E27FC236}">
-                <a16:creationId xmlns:a16="http://schemas.microsoft.com/office/drawing/2014/main" id="{406C856D-0567-42BE-959A-E52B6A289B39}"/>
+                <a16:creationId xmlns:a16="http://schemas.microsoft.com/office/drawing/2014/main" id="{604B22CE-FBBB-47AF-B8D8-258FAEE14C94}"/>
               </a:ext>
             </a:extLst>
           </p:cNvPr>
@@ -2247,7 +2947,7 @@
           <p:cNvPr id="3" name="Right column">
             <a:extLst xmlns:a="http://schemas.openxmlformats.org/drawingml/2006/main">
               <a:ext uri="{FF2B5EF4-FFF2-40B4-BE49-F238E27FC236}">
-                <a16:creationId xmlns:a16="http://schemas.microsoft.com/office/drawing/2014/main" id="{C9A74224-2A3C-4429-8210-27B5C2B15AE0}"/>
+                <a16:creationId xmlns:a16="http://schemas.microsoft.com/office/drawing/2014/main" id="{B18B9A27-E294-4E7C-A199-0C3CCC831EBC}"/>
               </a:ext>
             </a:extLst>
           </p:cNvPr>
@@ -2430,7 +3130,7 @@
           <p:cNvPr id="3" name="Title">
             <a:extLst xmlns:a="http://schemas.openxmlformats.org/drawingml/2006/main">
               <a:ext uri="{FF2B5EF4-FFF2-40B4-BE49-F238E27FC236}">
-                <a16:creationId xmlns:a16="http://schemas.microsoft.com/office/drawing/2014/main" id="{F780D093-E26B-4F28-A2A0-2B710C9F3821}"/>
+                <a16:creationId xmlns:a16="http://schemas.microsoft.com/office/drawing/2014/main" id="{E8E1359C-83B4-4D27-80CA-1679B304CA9C}"/>
               </a:ext>
             </a:extLst>
           </p:cNvPr>
@@ -2596,7 +3296,7 @@
           <p:cNvPr id="2" name="Left column">
             <a:extLst xmlns:a="http://schemas.openxmlformats.org/drawingml/2006/main">
               <a:ext uri="{FF2B5EF4-FFF2-40B4-BE49-F238E27FC236}">
-                <a16:creationId xmlns:a16="http://schemas.microsoft.com/office/drawing/2014/main" id="{BCDDF9D0-C90B-4E92-8F3F-0E23D1FA7927}"/>
+                <a16:creationId xmlns:a16="http://schemas.microsoft.com/office/drawing/2014/main" id="{8CB3945C-8176-45BA-9FB6-3896AAD0060E}"/>
               </a:ext>
             </a:extLst>
           </p:cNvPr>
@@ -2800,12 +3500,12 @@
   </p:cSld>
   <p:clrMap bg1="lt1" tx1="dk1" bg2="lt2" tx2="dk2" accent1="accent1" accent2="accent2" accent3="accent3" accent4="accent4" accent5="accent5" accent6="accent6" hlink="hlink" folHlink="folHlink"/>
   <p:sldLayoutIdLst>
-    <p:sldLayoutId xmlns:r="http://schemas.openxmlformats.org/officeDocument/2006/relationships" id="2147483649" r:id="R0dcb1fa4ceff4d88"/>
-    <p:sldLayoutId xmlns:r="http://schemas.openxmlformats.org/officeDocument/2006/relationships" id="2147483650" r:id="R329a2dca30a7420e"/>
-    <p:sldLayoutId xmlns:r="http://schemas.openxmlformats.org/officeDocument/2006/relationships" id="2147483651" r:id="R34887fc5133a4a30"/>
-    <p:sldLayoutId xmlns:r="http://schemas.openxmlformats.org/officeDocument/2006/relationships" id="2147483652" r:id="R87f7bbabb5874fe6"/>
-    <p:sldLayoutId xmlns:r="http://schemas.openxmlformats.org/officeDocument/2006/relationships" id="2147483653" r:id="Rb10b97963d0f4fcc"/>
-    <p:sldLayoutId xmlns:r="http://schemas.openxmlformats.org/officeDocument/2006/relationships" id="2147483654" r:id="Rd7872c1de0da496f"/>
+    <p:sldLayoutId xmlns:r="http://schemas.openxmlformats.org/officeDocument/2006/relationships" id="2147483649" r:id="R5a4e67cf24e24b19"/>
+    <p:sldLayoutId xmlns:r="http://schemas.openxmlformats.org/officeDocument/2006/relationships" id="2147483650" r:id="Rdbbb0f5f5be24d47"/>
+    <p:sldLayoutId xmlns:r="http://schemas.openxmlformats.org/officeDocument/2006/relationships" id="2147483651" r:id="R8ee04579ef254723"/>
+    <p:sldLayoutId xmlns:r="http://schemas.openxmlformats.org/officeDocument/2006/relationships" id="2147483652" r:id="Ra80e94c61af3416c"/>
+    <p:sldLayoutId xmlns:r="http://schemas.openxmlformats.org/officeDocument/2006/relationships" id="2147483653" r:id="R41e2abd217e446fa"/>
+    <p:sldLayoutId xmlns:r="http://schemas.openxmlformats.org/officeDocument/2006/relationships" id="2147483654" r:id="R678fd442653e409a"/>
   </p:sldLayoutIdLst>
   <p:txStyles>
     <p:titleStyle>
@@ -3356,7 +4056,7 @@
           <p:cNvPr id="31" name="">
             <a:extLst xmlns:a="http://schemas.openxmlformats.org/drawingml/2006/main">
               <a:ext uri="{FF2B5EF4-FFF2-40B4-BE49-F238E27FC236}">
-                <a16:creationId xmlns:a16="http://schemas.microsoft.com/office/drawing/2014/main" id="{921A90D3-F8D4-4077-94AA-CDD4DA3E4209}"/>
+                <a16:creationId xmlns:a16="http://schemas.microsoft.com/office/drawing/2014/main" id="{A6531556-4AC9-446D-AFFD-6D0C43FCA364}"/>
               </a:ext>
             </a:extLst>
           </p:cNvPr>
@@ -3366,7 +4066,7 @@
           <p:nvPr/>
         </p:nvPicPr>
         <p:blipFill>
-          <a:blip xmlns:r="http://schemas.openxmlformats.org/officeDocument/2006/relationships" xmlns:a="http://schemas.openxmlformats.org/drawingml/2006/main" r:embed="Rfe5906854db94493"/>
+          <a:blip xmlns:r="http://schemas.openxmlformats.org/officeDocument/2006/relationships" xmlns:a="http://schemas.openxmlformats.org/drawingml/2006/main" r:embed="Rd07c59fa3eb64858"/>
           <a:stretch xmlns:a="http://schemas.openxmlformats.org/drawingml/2006/main"/>
         </p:blipFill>
         <p:spPr>
@@ -3384,7 +4084,7 @@
           <p:cNvPr id="2" name="Figure 2 label 1 line 1">
             <a:extLst xmlns:a="http://schemas.openxmlformats.org/drawingml/2006/main">
               <a:ext uri="{FF2B5EF4-FFF2-40B4-BE49-F238E27FC236}">
-                <a16:creationId xmlns:a16="http://schemas.microsoft.com/office/drawing/2014/main" id="{3BB9F6D3-30B2-4E62-864A-11EF799B8043}"/>
+                <a16:creationId xmlns:a16="http://schemas.microsoft.com/office/drawing/2014/main" id="{6FC7EA70-5C91-4B43-AADE-AAA04D440D8B}"/>
               </a:ext>
             </a:extLst>
           </p:cNvPr>
@@ -3454,7 +4154,7 @@
           <p:cNvPr id="3" name="Figure 2 label 2 line 1">
             <a:extLst xmlns:a="http://schemas.openxmlformats.org/drawingml/2006/main">
               <a:ext uri="{FF2B5EF4-FFF2-40B4-BE49-F238E27FC236}">
-                <a16:creationId xmlns:a16="http://schemas.microsoft.com/office/drawing/2014/main" id="{700297A8-56BE-4C0F-A3D8-4F27074FD46F}"/>
+                <a16:creationId xmlns:a16="http://schemas.microsoft.com/office/drawing/2014/main" id="{C144B332-3179-4683-B055-7FD0C2DFE150}"/>
               </a:ext>
             </a:extLst>
           </p:cNvPr>
@@ -3524,7 +4224,7 @@
           <p:cNvPr id="4" name="Figure 2 label 3 line 1">
             <a:extLst xmlns:a="http://schemas.openxmlformats.org/drawingml/2006/main">
               <a:ext uri="{FF2B5EF4-FFF2-40B4-BE49-F238E27FC236}">
-                <a16:creationId xmlns:a16="http://schemas.microsoft.com/office/drawing/2014/main" id="{A8C6184F-7152-41E9-90FB-88874F7AC0D7}"/>
+                <a16:creationId xmlns:a16="http://schemas.microsoft.com/office/drawing/2014/main" id="{BEB90B89-5DCB-48B6-B5A0-5A161A7A3B1D}"/>
               </a:ext>
             </a:extLst>
           </p:cNvPr>
@@ -3594,7 +4294,7 @@
           <p:cNvPr id="5" name="Figure 2 label 4 line 1">
             <a:extLst xmlns:a="http://schemas.openxmlformats.org/drawingml/2006/main">
               <a:ext uri="{FF2B5EF4-FFF2-40B4-BE49-F238E27FC236}">
-                <a16:creationId xmlns:a16="http://schemas.microsoft.com/office/drawing/2014/main" id="{8266644F-212F-40D2-9C70-197DFBC47994}"/>
+                <a16:creationId xmlns:a16="http://schemas.microsoft.com/office/drawing/2014/main" id="{949D85C4-7D96-4214-9955-92F02563F936}"/>
               </a:ext>
             </a:extLst>
           </p:cNvPr>
@@ -3664,7 +4364,7 @@
           <p:cNvPr id="6" name="Figure 2 label 5 line 1">
             <a:extLst xmlns:a="http://schemas.openxmlformats.org/drawingml/2006/main">
               <a:ext uri="{FF2B5EF4-FFF2-40B4-BE49-F238E27FC236}">
-                <a16:creationId xmlns:a16="http://schemas.microsoft.com/office/drawing/2014/main" id="{69743F06-C418-42B1-A372-28753874672E}"/>
+                <a16:creationId xmlns:a16="http://schemas.microsoft.com/office/drawing/2014/main" id="{C142AF81-BCBB-4607-B1AC-4FDFF2F5FB87}"/>
               </a:ext>
             </a:extLst>
           </p:cNvPr>
@@ -3734,7 +4434,7 @@
           <p:cNvPr id="7" name="Figure 2 label 6 line 1">
             <a:extLst xmlns:a="http://schemas.openxmlformats.org/drawingml/2006/main">
               <a:ext uri="{FF2B5EF4-FFF2-40B4-BE49-F238E27FC236}">
-                <a16:creationId xmlns:a16="http://schemas.microsoft.com/office/drawing/2014/main" id="{CD4F10CF-6898-4EC4-BC6C-7EDF44344B39}"/>
+                <a16:creationId xmlns:a16="http://schemas.microsoft.com/office/drawing/2014/main" id="{A776D493-37CD-4AD7-836F-B4F946A651C2}"/>
               </a:ext>
             </a:extLst>
           </p:cNvPr>
@@ -3804,7 +4504,7 @@
           <p:cNvPr id="8" name="Figure 2 label 7 line 1">
             <a:extLst xmlns:a="http://schemas.openxmlformats.org/drawingml/2006/main">
               <a:ext uri="{FF2B5EF4-FFF2-40B4-BE49-F238E27FC236}">
-                <a16:creationId xmlns:a16="http://schemas.microsoft.com/office/drawing/2014/main" id="{F7696042-D0D9-4BA1-95AB-80A1BED157FB}"/>
+                <a16:creationId xmlns:a16="http://schemas.microsoft.com/office/drawing/2014/main" id="{94E7724B-FE04-4AAF-A82B-58098A0B6F54}"/>
               </a:ext>
             </a:extLst>
           </p:cNvPr>
@@ -3874,7 +4574,7 @@
           <p:cNvPr id="9" name="Figure 2 label 8 line 1">
             <a:extLst xmlns:a="http://schemas.openxmlformats.org/drawingml/2006/main">
               <a:ext uri="{FF2B5EF4-FFF2-40B4-BE49-F238E27FC236}">
-                <a16:creationId xmlns:a16="http://schemas.microsoft.com/office/drawing/2014/main" id="{E7CF1899-874E-4D9F-A8E3-DD1C751CD72E}"/>
+                <a16:creationId xmlns:a16="http://schemas.microsoft.com/office/drawing/2014/main" id="{D5809CF3-5A6C-4F4B-80BF-9D2D362F26CF}"/>
               </a:ext>
             </a:extLst>
           </p:cNvPr>
@@ -3944,7 +4644,7 @@
           <p:cNvPr id="10" name="Figure 2 label 9 line 1">
             <a:extLst xmlns:a="http://schemas.openxmlformats.org/drawingml/2006/main">
               <a:ext uri="{FF2B5EF4-FFF2-40B4-BE49-F238E27FC236}">
-                <a16:creationId xmlns:a16="http://schemas.microsoft.com/office/drawing/2014/main" id="{802EF9E5-82BC-44FC-80C9-32473086772E}"/>
+                <a16:creationId xmlns:a16="http://schemas.microsoft.com/office/drawing/2014/main" id="{63B5BDA2-BED4-44B0-ABD5-C4DA8F80AD09}"/>
               </a:ext>
             </a:extLst>
           </p:cNvPr>
@@ -4014,7 +4714,7 @@
           <p:cNvPr id="11" name="Figure 2 label 10 line 1">
             <a:extLst xmlns:a="http://schemas.openxmlformats.org/drawingml/2006/main">
               <a:ext uri="{FF2B5EF4-FFF2-40B4-BE49-F238E27FC236}">
-                <a16:creationId xmlns:a16="http://schemas.microsoft.com/office/drawing/2014/main" id="{1202730D-5976-4239-A894-6138528CFC0F}"/>
+                <a16:creationId xmlns:a16="http://schemas.microsoft.com/office/drawing/2014/main" id="{DF88A77C-E4FE-47C4-83A9-3F3A09964603}"/>
               </a:ext>
             </a:extLst>
           </p:cNvPr>
@@ -4084,7 +4784,7 @@
           <p:cNvPr id="12" name="Figure 2 label 11 line 1">
             <a:extLst xmlns:a="http://schemas.openxmlformats.org/drawingml/2006/main">
               <a:ext uri="{FF2B5EF4-FFF2-40B4-BE49-F238E27FC236}">
-                <a16:creationId xmlns:a16="http://schemas.microsoft.com/office/drawing/2014/main" id="{EBAC8EF3-9F05-42B5-9369-CC94A309C254}"/>
+                <a16:creationId xmlns:a16="http://schemas.microsoft.com/office/drawing/2014/main" id="{2885808D-6695-436A-A493-ED13AA4F3E74}"/>
               </a:ext>
             </a:extLst>
           </p:cNvPr>
@@ -4154,7 +4854,7 @@
           <p:cNvPr id="13" name="Figure 2 label 12 line 1">
             <a:extLst xmlns:a="http://schemas.openxmlformats.org/drawingml/2006/main">
               <a:ext uri="{FF2B5EF4-FFF2-40B4-BE49-F238E27FC236}">
-                <a16:creationId xmlns:a16="http://schemas.microsoft.com/office/drawing/2014/main" id="{BD9BAF87-13C2-403D-9ABD-8175805F5996}"/>
+                <a16:creationId xmlns:a16="http://schemas.microsoft.com/office/drawing/2014/main" id="{B4911373-6788-4AEE-BD51-3DD4BE05A3FF}"/>
               </a:ext>
             </a:extLst>
           </p:cNvPr>
@@ -4224,7 +4924,7 @@
           <p:cNvPr id="14" name="Figure 2 label 13 line 1">
             <a:extLst xmlns:a="http://schemas.openxmlformats.org/drawingml/2006/main">
               <a:ext uri="{FF2B5EF4-FFF2-40B4-BE49-F238E27FC236}">
-                <a16:creationId xmlns:a16="http://schemas.microsoft.com/office/drawing/2014/main" id="{DE7080EE-4E62-4C27-96DC-5B56BF514AED}"/>
+                <a16:creationId xmlns:a16="http://schemas.microsoft.com/office/drawing/2014/main" id="{08B553CC-F092-4F31-9F6C-BAA72124F019}"/>
               </a:ext>
             </a:extLst>
           </p:cNvPr>
@@ -4294,7 +4994,7 @@
           <p:cNvPr id="15" name="Figure 2 label 14 line 1">
             <a:extLst xmlns:a="http://schemas.openxmlformats.org/drawingml/2006/main">
               <a:ext uri="{FF2B5EF4-FFF2-40B4-BE49-F238E27FC236}">
-                <a16:creationId xmlns:a16="http://schemas.microsoft.com/office/drawing/2014/main" id="{D5AC33F6-3800-4B6A-82AA-6B2416DF2B65}"/>
+                <a16:creationId xmlns:a16="http://schemas.microsoft.com/office/drawing/2014/main" id="{9A732F65-11F8-4641-9F93-55201BDC7C60}"/>
               </a:ext>
             </a:extLst>
           </p:cNvPr>
@@ -4364,7 +5064,7 @@
           <p:cNvPr id="16" name="Figure 2 label 15 line 1">
             <a:extLst xmlns:a="http://schemas.openxmlformats.org/drawingml/2006/main">
               <a:ext uri="{FF2B5EF4-FFF2-40B4-BE49-F238E27FC236}">
-                <a16:creationId xmlns:a16="http://schemas.microsoft.com/office/drawing/2014/main" id="{2BE28B9A-7A63-451C-ADFA-C02399DD7E6B}"/>
+                <a16:creationId xmlns:a16="http://schemas.microsoft.com/office/drawing/2014/main" id="{3DF6E803-ABCA-4CB4-96B5-F899CB51D985}"/>
               </a:ext>
             </a:extLst>
           </p:cNvPr>
@@ -4392,7 +5092,7 @@
             <a:defPPr algn="l">
               <a:defRPr sz="1313" b="0">
                 <a:solidFill>
-                  <a:srgbClr val="000000"/>
+                  <a:srgbClr val="00355F"/>
                 </a:solidFill>
                 <a:latin typeface="Arial Unicode MS"/>
                 <a:ea typeface="Arial Unicode MS"/>
@@ -4408,7 +5108,7 @@
               <a:buNone/>
               <a:defRPr sz="1313" b="0">
                 <a:solidFill>
-                  <a:srgbClr val="000000"/>
+                  <a:srgbClr val="00355F"/>
                 </a:solidFill>
                 <a:latin typeface="Arial Unicode MS"/>
                 <a:ea typeface="Arial Unicode MS"/>
@@ -4418,7 +5118,7 @@
             <a:r>
               <a:rPr sz="1313" b="0">
                 <a:solidFill>
-                  <a:srgbClr val="000000"/>
+                  <a:srgbClr val="00355F"/>
                 </a:solidFill>
                 <a:latin typeface="Arial Unicode MS"/>
                 <a:ea typeface="Arial Unicode MS"/>
@@ -4434,7 +5134,7 @@
           <p:cNvPr id="17" name="Figure 2 label 16 line 1">
             <a:extLst xmlns:a="http://schemas.openxmlformats.org/drawingml/2006/main">
               <a:ext uri="{FF2B5EF4-FFF2-40B4-BE49-F238E27FC236}">
-                <a16:creationId xmlns:a16="http://schemas.microsoft.com/office/drawing/2014/main" id="{22116782-1244-44C0-8686-E72BB1BFC73C}"/>
+                <a16:creationId xmlns:a16="http://schemas.microsoft.com/office/drawing/2014/main" id="{65270581-8955-457C-BCD8-E05E251FDE73}"/>
               </a:ext>
             </a:extLst>
           </p:cNvPr>
@@ -4462,7 +5162,7 @@
             <a:defPPr algn="l">
               <a:defRPr sz="1313" b="0">
                 <a:solidFill>
-                  <a:srgbClr val="000000"/>
+                  <a:srgbClr val="00355F"/>
                 </a:solidFill>
                 <a:latin typeface="Arial Unicode MS"/>
                 <a:ea typeface="Arial Unicode MS"/>
@@ -4478,7 +5178,7 @@
               <a:buNone/>
               <a:defRPr sz="1313" b="0">
                 <a:solidFill>
-                  <a:srgbClr val="000000"/>
+                  <a:srgbClr val="00355F"/>
                 </a:solidFill>
                 <a:latin typeface="Arial Unicode MS"/>
                 <a:ea typeface="Arial Unicode MS"/>
@@ -4488,7 +5188,7 @@
             <a:r>
               <a:rPr sz="1313" b="0">
                 <a:solidFill>
-                  <a:srgbClr val="000000"/>
+                  <a:srgbClr val="00355F"/>
                 </a:solidFill>
                 <a:latin typeface="Arial Unicode MS"/>
                 <a:ea typeface="Arial Unicode MS"/>
@@ -4504,7 +5204,7 @@
           <p:cNvPr id="18" name="Figure 2 label 17 line 1">
             <a:extLst xmlns:a="http://schemas.openxmlformats.org/drawingml/2006/main">
               <a:ext uri="{FF2B5EF4-FFF2-40B4-BE49-F238E27FC236}">
-                <a16:creationId xmlns:a16="http://schemas.microsoft.com/office/drawing/2014/main" id="{0240EB9E-9140-4C75-96A6-12BDFD749D12}"/>
+                <a16:creationId xmlns:a16="http://schemas.microsoft.com/office/drawing/2014/main" id="{1525531A-2C2C-4EED-944B-7464DF63BD85}"/>
               </a:ext>
             </a:extLst>
           </p:cNvPr>
@@ -4515,8 +5215,8 @@
         </p:nvSpPr>
         <p:spPr>
           <a:xfrm xmlns:a="http://schemas.openxmlformats.org/drawingml/2006/main" rot="0">
-            <a:off x="991870" y="421920"/>
-            <a:ext cx="5409654" cy="436563"/>
+            <a:off x="991870" y="421675"/>
+            <a:ext cx="6167338" cy="436563"/>
           </a:xfrm>
           <a:prstGeom xmlns:a="http://schemas.openxmlformats.org/drawingml/2006/main" prst="rect">
             <a:avLst/>
@@ -4564,7 +5264,7 @@
                 <a:ea typeface="Arial Unicode MS"/>
                 <a:cs typeface="Arial Unicode MS"/>
               </a:rPr>
-              <a:t>02  China and global LST markets</a:t>
+              <a:t>02  2025 LST under one F&amp;S definition</a:t>
             </a:r>
           </a:p>
         </p:txBody>
@@ -4574,7 +5274,7 @@
           <p:cNvPr id="19" name="Figure 2 label 18 line 1">
             <a:extLst xmlns:a="http://schemas.openxmlformats.org/drawingml/2006/main">
               <a:ext uri="{FF2B5EF4-FFF2-40B4-BE49-F238E27FC236}">
-                <a16:creationId xmlns:a16="http://schemas.microsoft.com/office/drawing/2014/main" id="{E221D811-1BFD-474A-9737-45FF71C1E7ED}"/>
+                <a16:creationId xmlns:a16="http://schemas.microsoft.com/office/drawing/2014/main" id="{A11493A4-F0A1-4E19-BB17-BE52E8E88719}"/>
               </a:ext>
             </a:extLst>
           </p:cNvPr>
@@ -4644,7 +5344,7 @@
           <p:cNvPr id="20" name="Figure 2 label 19 line 1">
             <a:extLst xmlns:a="http://schemas.openxmlformats.org/drawingml/2006/main">
               <a:ext uri="{FF2B5EF4-FFF2-40B4-BE49-F238E27FC236}">
-                <a16:creationId xmlns:a16="http://schemas.microsoft.com/office/drawing/2014/main" id="{E64F86F9-5E1A-4E4A-859D-6B0B31824527}"/>
+                <a16:creationId xmlns:a16="http://schemas.microsoft.com/office/drawing/2014/main" id="{F0548728-10E1-4EB3-AD81-EB9DD48FDE05}"/>
               </a:ext>
             </a:extLst>
           </p:cNvPr>
@@ -4656,7 +5356,7 @@
         <p:spPr>
           <a:xfrm xmlns:a="http://schemas.openxmlformats.org/drawingml/2006/main" rot="0">
             <a:off x="998220" y="1249487"/>
-            <a:ext cx="8837861" cy="238125"/>
+            <a:ext cx="8350746" cy="238125"/>
           </a:xfrm>
           <a:prstGeom xmlns:a="http://schemas.openxmlformats.org/drawingml/2006/main" prst="rect">
             <a:avLst/>
@@ -4704,7 +5404,7 @@
                 <a:ea typeface="Arial Unicode MS"/>
                 <a:cs typeface="Arial Unicode MS"/>
               </a:rPr>
-              <a:t>2025 historical estimates from one F&amp;S study; this is a defined market scope, not a universal LST TAM.</a:t>
+              <a:t>2025 F&amp;S estimates commissioned for ACRO’s filing. A defined scope, not a broad-industry TAM.</a:t>
             </a:r>
           </a:p>
         </p:txBody>
@@ -4714,7 +5414,7 @@
           <p:cNvPr id="21" name="Figure 2 label 20 line 1">
             <a:extLst xmlns:a="http://schemas.openxmlformats.org/drawingml/2006/main">
               <a:ext uri="{FF2B5EF4-FFF2-40B4-BE49-F238E27FC236}">
-                <a16:creationId xmlns:a16="http://schemas.microsoft.com/office/drawing/2014/main" id="{0E4DC5F6-02AF-410C-9AD0-7961E8CDCE06}"/>
+                <a16:creationId xmlns:a16="http://schemas.microsoft.com/office/drawing/2014/main" id="{4866BE39-F020-4184-94BF-D318EC6C2CE3}"/>
               </a:ext>
             </a:extLst>
           </p:cNvPr>
@@ -4784,7 +5484,7 @@
           <p:cNvPr id="22" name="Figure 2 label 21 line 1">
             <a:extLst xmlns:a="http://schemas.openxmlformats.org/drawingml/2006/main">
               <a:ext uri="{FF2B5EF4-FFF2-40B4-BE49-F238E27FC236}">
-                <a16:creationId xmlns:a16="http://schemas.microsoft.com/office/drawing/2014/main" id="{22459D7D-9D34-4933-80FA-193ED12255DE}"/>
+                <a16:creationId xmlns:a16="http://schemas.microsoft.com/office/drawing/2014/main" id="{72EC350A-3E2D-4F40-B5B5-1BC9423B1B02}"/>
               </a:ext>
             </a:extLst>
           </p:cNvPr>
@@ -4854,7 +5554,7 @@
           <p:cNvPr id="23" name="Figure 2 label 22 line 1">
             <a:extLst xmlns:a="http://schemas.openxmlformats.org/drawingml/2006/main">
               <a:ext uri="{FF2B5EF4-FFF2-40B4-BE49-F238E27FC236}">
-                <a16:creationId xmlns:a16="http://schemas.microsoft.com/office/drawing/2014/main" id="{08C4ADD7-7FFB-4763-9675-F7DB2EF0F5C6}"/>
+                <a16:creationId xmlns:a16="http://schemas.microsoft.com/office/drawing/2014/main" id="{B1D55378-1A62-4C4A-88FA-56A37D009393}"/>
               </a:ext>
             </a:extLst>
           </p:cNvPr>
@@ -4914,7 +5614,7 @@
                 <a:ea typeface="Arial Unicode MS"/>
                 <a:cs typeface="Arial Unicode MS"/>
               </a:rPr>
-              <a:t>2026-10-12</a:t>
+              <a:t>2026-10-13</a:t>
             </a:r>
           </a:p>
         </p:txBody>
@@ -4924,7 +5624,7 @@
           <p:cNvPr id="24" name="Figure 2 label 23 line 1">
             <a:extLst xmlns:a="http://schemas.openxmlformats.org/drawingml/2006/main">
               <a:ext uri="{FF2B5EF4-FFF2-40B4-BE49-F238E27FC236}">
-                <a16:creationId xmlns:a16="http://schemas.microsoft.com/office/drawing/2014/main" id="{13C47A34-DEF0-43F4-AEF7-DF0D26FE553D}"/>
+                <a16:creationId xmlns:a16="http://schemas.microsoft.com/office/drawing/2014/main" id="{3B8D8DE4-CD7F-4D7C-8CCD-15E069A7687B}"/>
               </a:ext>
             </a:extLst>
           </p:cNvPr>
@@ -4935,8 +5635,8 @@
         </p:nvSpPr>
         <p:spPr>
           <a:xfrm xmlns:a="http://schemas.openxmlformats.org/drawingml/2006/main" rot="0">
-            <a:off x="13159106" y="3177838"/>
-            <a:ext cx="2083643" cy="257969"/>
+            <a:off x="13159106" y="3178951"/>
+            <a:ext cx="2897882" cy="257969"/>
           </a:xfrm>
           <a:prstGeom xmlns:a="http://schemas.openxmlformats.org/drawingml/2006/main" prst="rect">
             <a:avLst/>
@@ -4984,7 +5684,7 @@
                 <a:ea typeface="Arial Unicode MS"/>
                 <a:cs typeface="Arial Unicode MS"/>
               </a:rPr>
-              <a:t>China / global market</a:t>
+              <a:t>China share within F&amp;S scope</a:t>
             </a:r>
           </a:p>
         </p:txBody>
@@ -4994,7 +5694,7 @@
           <p:cNvPr id="25" name="Figure 2 label 24 line 1">
             <a:extLst xmlns:a="http://schemas.openxmlformats.org/drawingml/2006/main">
               <a:ext uri="{FF2B5EF4-FFF2-40B4-BE49-F238E27FC236}">
-                <a16:creationId xmlns:a16="http://schemas.microsoft.com/office/drawing/2014/main" id="{78C3181C-F1E2-4E2B-A8FA-E36FC14D1D7D}"/>
+                <a16:creationId xmlns:a16="http://schemas.microsoft.com/office/drawing/2014/main" id="{8D6BF348-0403-4AD1-A523-89F5019C9F96}"/>
               </a:ext>
             </a:extLst>
           </p:cNvPr>
@@ -5064,7 +5764,7 @@
           <p:cNvPr id="26" name="Figure 2 label 25 line 1">
             <a:extLst xmlns:a="http://schemas.openxmlformats.org/drawingml/2006/main">
               <a:ext uri="{FF2B5EF4-FFF2-40B4-BE49-F238E27FC236}">
-                <a16:creationId xmlns:a16="http://schemas.microsoft.com/office/drawing/2014/main" id="{79DFF641-BA23-453A-B2B5-C819D5967894}"/>
+                <a16:creationId xmlns:a16="http://schemas.microsoft.com/office/drawing/2014/main" id="{83F44E64-F908-4599-96E0-B156AF3BC1C0}"/>
               </a:ext>
             </a:extLst>
           </p:cNvPr>
@@ -5075,7 +5775,7 @@
         </p:nvSpPr>
         <p:spPr>
           <a:xfrm xmlns:a="http://schemas.openxmlformats.org/drawingml/2006/main" rot="0">
-            <a:off x="13159740" y="4881351"/>
+            <a:off x="13159740" y="4882744"/>
             <a:ext cx="918270" cy="238125"/>
           </a:xfrm>
           <a:prstGeom xmlns:a="http://schemas.openxmlformats.org/drawingml/2006/main" prst="rect">
@@ -5134,7 +5834,7 @@
           <p:cNvPr id="27" name="Figure 2 label 26 line 1">
             <a:extLst xmlns:a="http://schemas.openxmlformats.org/drawingml/2006/main">
               <a:ext uri="{FF2B5EF4-FFF2-40B4-BE49-F238E27FC236}">
-                <a16:creationId xmlns:a16="http://schemas.microsoft.com/office/drawing/2014/main" id="{58D69D64-5BAA-4029-99AD-041C0371C39F}"/>
+                <a16:creationId xmlns:a16="http://schemas.microsoft.com/office/drawing/2014/main" id="{F013DC80-4F6B-4352-9F9C-329453845DE8}"/>
               </a:ext>
             </a:extLst>
           </p:cNvPr>
@@ -5145,8 +5845,8 @@
         </p:nvSpPr>
         <p:spPr>
           <a:xfrm xmlns:a="http://schemas.openxmlformats.org/drawingml/2006/main" rot="0">
-            <a:off x="13159740" y="5085716"/>
-            <a:ext cx="2770733" cy="238125"/>
+            <a:off x="13159740" y="5084323"/>
+            <a:ext cx="2633663" cy="238125"/>
           </a:xfrm>
           <a:prstGeom xmlns:a="http://schemas.openxmlformats.org/drawingml/2006/main" prst="rect">
             <a:avLst/>
@@ -5194,7 +5894,7 @@
                 <a:ea typeface="Arial Unicode MS"/>
                 <a:cs typeface="Arial Unicode MS"/>
               </a:rPr>
-              <a:t>Same-scope historical estimate</a:t>
+              <a:t>Not vendor revenue exposure</a:t>
             </a:r>
           </a:p>
         </p:txBody>
@@ -5204,7 +5904,7 @@
           <p:cNvPr id="28" name="Figure 2 label 27 line 1">
             <a:extLst xmlns:a="http://schemas.openxmlformats.org/drawingml/2006/main">
               <a:ext uri="{FF2B5EF4-FFF2-40B4-BE49-F238E27FC236}">
-                <a16:creationId xmlns:a16="http://schemas.microsoft.com/office/drawing/2014/main" id="{26A9019E-BA1F-41C4-B597-208986739C57}"/>
+                <a16:creationId xmlns:a16="http://schemas.microsoft.com/office/drawing/2014/main" id="{48DB0190-F2A3-4E78-A611-4C9F36EFF03E}"/>
               </a:ext>
             </a:extLst>
           </p:cNvPr>
@@ -5215,8 +5915,8 @@
         </p:nvSpPr>
         <p:spPr>
           <a:xfrm xmlns:a="http://schemas.openxmlformats.org/drawingml/2006/main" rot="0">
-            <a:off x="12885420" y="6438162"/>
-            <a:ext cx="1966466" cy="238125"/>
+            <a:off x="12885420" y="6436769"/>
+            <a:ext cx="2749451" cy="238125"/>
           </a:xfrm>
           <a:prstGeom xmlns:a="http://schemas.openxmlformats.org/drawingml/2006/main" prst="rect">
             <a:avLst/>
@@ -5264,7 +5964,7 @@
                 <a:ea typeface="Arial Unicode MS"/>
                 <a:cs typeface="Arial Unicode MS"/>
               </a:rPr>
-              <a:t>Broader research and</a:t>
+              <a:t>Issuer-commissioned estimate.</a:t>
             </a:r>
           </a:p>
         </p:txBody>
@@ -5274,7 +5974,7 @@
           <p:cNvPr id="29" name="Figure 2 label 28 line 1">
             <a:extLst xmlns:a="http://schemas.openxmlformats.org/drawingml/2006/main">
               <a:ext uri="{FF2B5EF4-FFF2-40B4-BE49-F238E27FC236}">
-                <a16:creationId xmlns:a16="http://schemas.microsoft.com/office/drawing/2014/main" id="{FF8BE049-07CD-40CC-B649-C5976B469CD6}"/>
+                <a16:creationId xmlns:a16="http://schemas.microsoft.com/office/drawing/2014/main" id="{DF36AA49-56D9-4815-8FBD-7ACD81041552}"/>
               </a:ext>
             </a:extLst>
           </p:cNvPr>
@@ -5285,8 +5985,8 @@
         </p:nvSpPr>
         <p:spPr>
           <a:xfrm xmlns:a="http://schemas.openxmlformats.org/drawingml/2006/main" rot="0">
-            <a:off x="12885420" y="6639740"/>
-            <a:ext cx="2389733" cy="238125"/>
+            <a:off x="12885420" y="6638348"/>
+            <a:ext cx="2538115" cy="238125"/>
           </a:xfrm>
           <a:prstGeom xmlns:a="http://schemas.openxmlformats.org/drawingml/2006/main" prst="rect">
             <a:avLst/>
@@ -5334,7 +6034,7 @@
                 <a:ea typeface="Arial Unicode MS"/>
                 <a:cs typeface="Arial Unicode MS"/>
               </a:rPr>
-              <a:t>production markets require</a:t>
+              <a:t>Broader markets and vendor</a:t>
             </a:r>
           </a:p>
         </p:txBody>
@@ -5344,7 +6044,7 @@
           <p:cNvPr id="30" name="Figure 2 label 29 line 1">
             <a:extLst xmlns:a="http://schemas.openxmlformats.org/drawingml/2006/main">
               <a:ext uri="{FF2B5EF4-FFF2-40B4-BE49-F238E27FC236}">
-                <a16:creationId xmlns:a16="http://schemas.microsoft.com/office/drawing/2014/main" id="{129BFB48-1B64-4EA7-8A52-279E584F47E4}"/>
+                <a16:creationId xmlns:a16="http://schemas.microsoft.com/office/drawing/2014/main" id="{E9C11A81-B502-441B-B675-DDF5111A5BBB}"/>
               </a:ext>
             </a:extLst>
           </p:cNvPr>
@@ -5355,8 +6055,8 @@
         </p:nvSpPr>
         <p:spPr>
           <a:xfrm xmlns:a="http://schemas.openxmlformats.org/drawingml/2006/main" rot="0">
-            <a:off x="12885420" y="6841319"/>
-            <a:ext cx="2803029" cy="238125"/>
+            <a:off x="12885420" y="6842713"/>
+            <a:ext cx="3014811" cy="238125"/>
           </a:xfrm>
           <a:prstGeom xmlns:a="http://schemas.openxmlformats.org/drawingml/2006/main" prst="rect">
             <a:avLst/>
@@ -5404,7 +6104,7 @@
                 <a:ea typeface="Arial Unicode MS"/>
                 <a:cs typeface="Arial Unicode MS"/>
               </a:rPr>
-              <a:t>a separate scope reconciliation.</a:t>
+              <a:t>China revenues use other scopes.</a:t>
             </a:r>
           </a:p>
         </p:txBody>
@@ -5412,7 +6112,7 @@
     </p:spTree>
     <p:extLst>
       <p:ext uri="{BB962C8B-B14F-4D97-AF65-F5344CB8AC3E}">
-        <p14:creationId xmlns:p14="http://schemas.microsoft.com/office/powerpoint/2010/main" val="2085822033"/>
+        <p14:creationId xmlns:p14="http://schemas.microsoft.com/office/powerpoint/2010/main" val="1241265664"/>
       </p:ext>
     </p:extLst>
   </p:cSld>

</xml_diff>